<commit_message>
Sprint B: marks in any corner, a watermark on every slide, livery_mpl from pip (#81) (#149)
</commit_message>
<xml_diff>
--- a/liveries/nasa-ccp/template.pptx
+++ b/liveries/nasa-ccp/template.pptx
@@ -673,8 +673,8 @@
         </p:nvSpPr>
         <p:spPr>
           <a:xfrm>
-            <a:off x="487680" y="1387373"/>
-            <a:ext cx="11216640" cy="5162017"/>
+            <a:off x="487680" y="1390802"/>
+            <a:ext cx="11216640" cy="5158588"/>
           </a:xfrm>
           <a:prstGeom prst="rect">
             <a:avLst/>
@@ -883,9 +883,33 @@
           </a:prstGeom>
         </p:spPr>
       </p:pic>
-      <p:sp>
-        <p:nvSpPr>
-          <p:cNvPr id="13" name="Title 1"/>
+      <p:pic>
+        <p:nvPicPr>
+          <p:cNvPr id="13" name="Sign-off (background)"/>
+          <p:cNvPicPr>
+            <a:picLocks noChangeAspect="1"/>
+          </p:cNvPicPr>
+          <p:nvPr userDrawn="1"/>
+        </p:nvPicPr>
+        <p:blipFill>
+          <a:blip r:embed="rId3"/>
+          <a:stretch>
+            <a:fillRect/>
+          </a:stretch>
+        </p:blipFill>
+        <p:spPr>
+          <a:xfrm>
+            <a:off x="11131296" y="510921"/>
+            <a:ext cx="882701" cy="726948"/>
+          </a:xfrm>
+          <a:prstGeom prst="rect">
+            <a:avLst/>
+          </a:prstGeom>
+        </p:spPr>
+      </p:pic>
+      <p:sp>
+        <p:nvSpPr>
+          <p:cNvPr id="14" name="Title 1"/>
           <p:cNvSpPr>
             <a:spLocks noGrp="1"/>
           </p:cNvSpPr>
@@ -929,7 +953,7 @@
       </p:sp>
       <p:sp>
         <p:nvSpPr>
-          <p:cNvPr id="14" name="Text Placeholder 2"/>
+          <p:cNvPr id="15" name="Text Placeholder 2"/>
           <p:cNvSpPr>
             <a:spLocks noGrp="1"/>
           </p:cNvSpPr>
@@ -974,7 +998,7 @@
       </p:sp>
       <p:sp>
         <p:nvSpPr>
-          <p:cNvPr id="15" name="Slide Number Placeholder"/>
+          <p:cNvPr id="16" name="Slide Number Placeholder"/>
           <p:cNvSpPr>
             <a:spLocks noGrp="1"/>
           </p:cNvSpPr>
@@ -1009,7 +1033,7 @@
       </p:sp>
       <p:sp>
         <p:nvSpPr>
-          <p:cNvPr id="16" name="Date Placeholder"/>
+          <p:cNvPr id="17" name="Date Placeholder"/>
           <p:cNvSpPr>
             <a:spLocks noGrp="1"/>
           </p:cNvSpPr>
@@ -1047,7 +1071,7 @@
       </p:sp>
       <p:sp>
         <p:nvSpPr>
-          <p:cNvPr id="17" name="Footer Placeholder"/>
+          <p:cNvPr id="18" name="Footer Placeholder"/>
           <p:cNvSpPr>
             <a:spLocks noGrp="1"/>
           </p:cNvSpPr>
@@ -1146,8 +1170,8 @@
         </p:nvSpPr>
         <p:spPr>
           <a:xfrm>
-            <a:off x="487680" y="1387373"/>
-            <a:ext cx="5425440" cy="5162017"/>
+            <a:off x="487680" y="1390802"/>
+            <a:ext cx="5425440" cy="5158588"/>
           </a:xfrm>
           <a:prstGeom prst="rect">
             <a:avLst/>
@@ -1176,8 +1200,8 @@
         </p:nvSpPr>
         <p:spPr>
           <a:xfrm>
-            <a:off x="6278880" y="1387373"/>
-            <a:ext cx="5425440" cy="5162017"/>
+            <a:off x="6278880" y="1390802"/>
+            <a:ext cx="5425440" cy="5158588"/>
           </a:xfrm>
           <a:prstGeom prst="rect">
             <a:avLst/>
@@ -1368,7 +1392,7 @@
         </p:nvSpPr>
         <p:spPr>
           <a:xfrm>
-            <a:off x="487680" y="1387373"/>
+            <a:off x="487680" y="1390802"/>
             <a:ext cx="5425440" cy="617220"/>
           </a:xfrm>
           <a:prstGeom prst="rect">
@@ -1409,8 +1433,8 @@
         </p:nvSpPr>
         <p:spPr>
           <a:xfrm>
-            <a:off x="487680" y="2073173"/>
-            <a:ext cx="5425440" cy="4476217"/>
+            <a:off x="487680" y="2076602"/>
+            <a:ext cx="5425440" cy="4472788"/>
           </a:xfrm>
           <a:prstGeom prst="rect">
             <a:avLst/>
@@ -1439,7 +1463,7 @@
         </p:nvSpPr>
         <p:spPr>
           <a:xfrm>
-            <a:off x="6278880" y="1387373"/>
+            <a:off x="6278880" y="1390802"/>
             <a:ext cx="5425440" cy="617220"/>
           </a:xfrm>
           <a:prstGeom prst="rect">
@@ -1480,8 +1504,8 @@
         </p:nvSpPr>
         <p:spPr>
           <a:xfrm>
-            <a:off x="6278880" y="2073173"/>
-            <a:ext cx="5425440" cy="4476217"/>
+            <a:off x="6278880" y="2076602"/>
+            <a:ext cx="5425440" cy="4472788"/>
           </a:xfrm>
           <a:prstGeom prst="rect">
             <a:avLst/>
@@ -1646,7 +1670,7 @@
         </p:nvSpPr>
         <p:spPr>
           <a:xfrm>
-            <a:off x="487680" y="1387373"/>
+            <a:off x="487680" y="1390802"/>
             <a:ext cx="4023360" cy="891540"/>
           </a:xfrm>
           <a:prstGeom prst="rect">
@@ -1682,8 +1706,8 @@
         </p:nvSpPr>
         <p:spPr>
           <a:xfrm>
-            <a:off x="4876800" y="1387373"/>
-            <a:ext cx="6827520" cy="5162017"/>
+            <a:off x="4876800" y="1390802"/>
+            <a:ext cx="6827520" cy="5158588"/>
           </a:xfrm>
           <a:prstGeom prst="rect">
             <a:avLst/>
@@ -1712,8 +1736,8 @@
         </p:nvSpPr>
         <p:spPr>
           <a:xfrm>
-            <a:off x="487680" y="2347493"/>
-            <a:ext cx="4023360" cy="4201897"/>
+            <a:off x="487680" y="2350922"/>
+            <a:ext cx="4023360" cy="4198468"/>
           </a:xfrm>
           <a:prstGeom prst="rect">
             <a:avLst/>
@@ -2653,8 +2677,8 @@
         </p:nvSpPr>
         <p:spPr>
           <a:xfrm>
-            <a:off x="1115375" y="480060"/>
-            <a:ext cx="9961249" cy="802386"/>
+            <a:off x="1365754" y="480060"/>
+            <a:ext cx="9460492" cy="802386"/>
           </a:xfrm>
           <a:prstGeom prst="rect">
             <a:avLst/>
@@ -2685,8 +2709,8 @@
         </p:nvSpPr>
         <p:spPr>
           <a:xfrm>
-            <a:off x="487680" y="1387373"/>
-            <a:ext cx="11216640" cy="5162017"/>
+            <a:off x="487680" y="1390802"/>
+            <a:ext cx="11216640" cy="5158588"/>
           </a:xfrm>
           <a:prstGeom prst="rect">
             <a:avLst/>
@@ -2708,7 +2732,7 @@
       </p:sp>
       <p:sp>
         <p:nvSpPr>
-          <p:cNvPr id="17" name="Slide Number Placeholder"/>
+          <p:cNvPr id="18" name="Slide Number Placeholder"/>
           <p:cNvSpPr>
             <a:spLocks noGrp="1"/>
           </p:cNvSpPr>
@@ -2743,7 +2767,7 @@
       </p:sp>
       <p:sp>
         <p:nvSpPr>
-          <p:cNvPr id="18" name="Date Placeholder"/>
+          <p:cNvPr id="19" name="Date Placeholder"/>
           <p:cNvSpPr>
             <a:spLocks noGrp="1"/>
           </p:cNvSpPr>
@@ -2781,7 +2805,7 @@
       </p:sp>
       <p:sp>
         <p:nvSpPr>
-          <p:cNvPr id="19" name="Footer Placeholder"/>
+          <p:cNvPr id="20" name="Footer Placeholder"/>
           <p:cNvSpPr>
             <a:spLocks noGrp="1"/>
           </p:cNvSpPr>
@@ -2835,6 +2859,30 @@
           <a:xfrm>
             <a:off x="97536" y="499262"/>
             <a:ext cx="713039" cy="733806"/>
+          </a:xfrm>
+          <a:prstGeom prst="rect">
+            <a:avLst/>
+          </a:prstGeom>
+        </p:spPr>
+      </p:pic>
+      <p:pic>
+        <p:nvPicPr>
+          <p:cNvPr id="17" name="Mark insignia (light)"/>
+          <p:cNvPicPr>
+            <a:picLocks noChangeAspect="1"/>
+          </p:cNvPicPr>
+          <p:nvPr userDrawn="1"/>
+        </p:nvPicPr>
+        <p:blipFill>
+          <a:blip r:embed="rId3"/>
+          <a:stretch>
+            <a:fillRect/>
+          </a:stretch>
+        </p:blipFill>
+        <p:spPr>
+          <a:xfrm>
+            <a:off x="11131046" y="510921"/>
+            <a:ext cx="882951" cy="726948"/>
           </a:xfrm>
           <a:prstGeom prst="rect">
             <a:avLst/>

</xml_diff>